<commit_message>
Fix all failing tests and improve test coverage - All 114 tests now pass
</commit_message>
<xml_diff>
--- a/tests/test_files/test_presentation.pptx
+++ b/tests/test_files/test_presentation.pptx
@@ -3095,37 +3095,16 @@
             <a:spLocks noGrp="1"/>
           </p:cNvSpPr>
           <p:nvPr>
-            <p:ph type="ctrTitle"/>
-          </p:nvPr>
-        </p:nvSpPr>
-        <p:spPr/>
-        <p:txBody>
-          <a:bodyPr/>
-          <a:lstStyle/>
-          <a:p>
-            <a:r>
-              <a:t>Тестовая презентация</a:t>
-            </a:r>
-          </a:p>
-        </p:txBody>
-      </p:sp>
-      <p:sp>
-        <p:nvSpPr>
-          <p:cNvPr id="3" name="Subtitle 2"/>
-          <p:cNvSpPr>
-            <a:spLocks noGrp="1"/>
-          </p:cNvSpPr>
-          <p:nvPr>
-            <p:ph type="subTitle" idx="1"/>
-          </p:nvPr>
-        </p:nvSpPr>
-        <p:spPr/>
-        <p:txBody>
-          <a:bodyPr/>
-          <a:lstStyle/>
-          <a:p>
-            <a:r>
-              <a:t>Для проверки очистки метаданных</a:t>
+            <p:ph type="title"/>
+          </p:nvPr>
+        </p:nvSpPr>
+        <p:spPr/>
+        <p:txBody>
+          <a:bodyPr/>
+          <a:lstStyle/>
+          <a:p>
+            <a:r>
+              <a:t>Top Secret World Domination Plan</a:t>
             </a:r>
           </a:p>
         </p:txBody>

</xml_diff>